<commit_message>
docs: add author affiliations to beehive slides
</commit_message>
<xml_diff>
--- a/beehive-monitoring/beehive-monitoring-ac4-slides-turma.pptx
+++ b/beehive-monitoring/beehive-monitoring-ac4-slides-turma.pptx
@@ -4657,6 +4657,41 @@
         </p:nvSpPr>
         <p:spPr>
           <a:xfrm>
+            <a:off x="1810512" y="1353312"/>
+            <a:ext cx="9464040" cy="274320"/>
+          </a:xfrm>
+          <a:prstGeom prst="rect">
+            <a:avLst/>
+          </a:prstGeom>
+          <a:noFill/>
+        </p:spPr>
+        <p:txBody>
+          <a:bodyPr wrap="square" lIns="18288" rIns="18288" tIns="18288" bIns="18288" anchor="t">
+            <a:spAutoFit/>
+          </a:bodyPr>
+          <a:lstStyle/>
+          <a:p>
+            <a:pPr algn="l"/>
+            <a:r>
+              <a:rPr sz="1400" b="1">
+                <a:solidFill>
+                  <a:srgbClr val="458CC4"/>
+                </a:solidFill>
+                <a:latin typeface="Arial"/>
+              </a:rPr>
+              <a:t>Zheng et al. · 2024 · Universiti Teknologi MARA (Malásia) + instituições chinesas</a:t>
+            </a:r>
+          </a:p>
+        </p:txBody>
+      </p:sp>
+      <p:sp>
+        <p:nvSpPr>
+          <p:cNvPr id="7" name="TextBox 6"/>
+          <p:cNvSpPr txBox="1"/>
+          <p:nvPr/>
+        </p:nvSpPr>
+        <p:spPr>
+          <a:xfrm>
             <a:off x="658368" y="1847088"/>
             <a:ext cx="4526280" cy="310896"/>
           </a:xfrm>
@@ -4686,7 +4721,7 @@
       </p:sp>
       <p:sp>
         <p:nvSpPr>
-          <p:cNvPr id="7" name="TextBox 6"/>
+          <p:cNvPr id="8" name="TextBox 7"/>
           <p:cNvSpPr txBox="1"/>
           <p:nvPr/>
         </p:nvSpPr>
@@ -4721,7 +4756,7 @@
       </p:sp>
       <p:sp>
         <p:nvSpPr>
-          <p:cNvPr id="8" name="Rectangle 7"/>
+          <p:cNvPr id="9" name="Rectangle 8"/>
           <p:cNvSpPr/>
           <p:nvPr/>
         </p:nvSpPr>
@@ -4766,7 +4801,7 @@
       </p:sp>
       <p:sp>
         <p:nvSpPr>
-          <p:cNvPr id="9" name="TextBox 8"/>
+          <p:cNvPr id="10" name="TextBox 9"/>
           <p:cNvSpPr txBox="1"/>
           <p:nvPr/>
         </p:nvSpPr>
@@ -4801,7 +4836,7 @@
       </p:sp>
       <p:sp>
         <p:nvSpPr>
-          <p:cNvPr id="10" name="TextBox 9"/>
+          <p:cNvPr id="11" name="TextBox 10"/>
           <p:cNvSpPr txBox="1"/>
           <p:nvPr/>
         </p:nvSpPr>
@@ -4836,7 +4871,7 @@
       </p:sp>
       <p:sp>
         <p:nvSpPr>
-          <p:cNvPr id="11" name="TextBox 10"/>
+          <p:cNvPr id="12" name="TextBox 11"/>
           <p:cNvSpPr txBox="1"/>
           <p:nvPr/>
         </p:nvSpPr>
@@ -4871,7 +4906,7 @@
       </p:sp>
       <p:sp>
         <p:nvSpPr>
-          <p:cNvPr id="12" name="Rectangle 11"/>
+          <p:cNvPr id="13" name="Rectangle 12"/>
           <p:cNvSpPr/>
           <p:nvPr/>
         </p:nvSpPr>
@@ -4916,7 +4951,7 @@
       </p:sp>
       <p:sp>
         <p:nvSpPr>
-          <p:cNvPr id="13" name="TextBox 12"/>
+          <p:cNvPr id="14" name="TextBox 13"/>
           <p:cNvSpPr txBox="1"/>
           <p:nvPr/>
         </p:nvSpPr>
@@ -4951,7 +4986,7 @@
       </p:sp>
       <p:sp>
         <p:nvSpPr>
-          <p:cNvPr id="14" name="TextBox 13"/>
+          <p:cNvPr id="15" name="TextBox 14"/>
           <p:cNvSpPr txBox="1"/>
           <p:nvPr/>
         </p:nvSpPr>
@@ -4986,7 +5021,7 @@
       </p:sp>
       <p:sp>
         <p:nvSpPr>
-          <p:cNvPr id="15" name="Rectangle 14"/>
+          <p:cNvPr id="16" name="Rectangle 15"/>
           <p:cNvSpPr/>
           <p:nvPr/>
         </p:nvSpPr>
@@ -5031,7 +5066,7 @@
       </p:sp>
       <p:sp>
         <p:nvSpPr>
-          <p:cNvPr id="16" name="TextBox 15"/>
+          <p:cNvPr id="17" name="TextBox 16"/>
           <p:cNvSpPr txBox="1"/>
           <p:nvPr/>
         </p:nvSpPr>
@@ -5066,7 +5101,7 @@
       </p:sp>
       <p:sp>
         <p:nvSpPr>
-          <p:cNvPr id="17" name="TextBox 16"/>
+          <p:cNvPr id="18" name="TextBox 17"/>
           <p:cNvSpPr txBox="1"/>
           <p:nvPr/>
         </p:nvSpPr>
@@ -5283,6 +5318,41 @@
         </p:nvSpPr>
         <p:spPr>
           <a:xfrm>
+            <a:off x="1810512" y="1353312"/>
+            <a:ext cx="9464040" cy="274320"/>
+          </a:xfrm>
+          <a:prstGeom prst="rect">
+            <a:avLst/>
+          </a:prstGeom>
+          <a:noFill/>
+        </p:spPr>
+        <p:txBody>
+          <a:bodyPr wrap="square" lIns="18288" rIns="18288" tIns="18288" bIns="18288" anchor="t">
+            <a:spAutoFit/>
+          </a:bodyPr>
+          <a:lstStyle/>
+          <a:p>
+            <a:pPr algn="l"/>
+            <a:r>
+              <a:rPr sz="1400" b="1">
+                <a:solidFill>
+                  <a:srgbClr val="DA6F5C"/>
+                </a:solidFill>
+                <a:latin typeface="Arial"/>
+              </a:rPr>
+              <a:t>Narcia-Macias et al. · 2024 · University of Texas Rio Grande Valley (EUA)</a:t>
+            </a:r>
+          </a:p>
+        </p:txBody>
+      </p:sp>
+      <p:sp>
+        <p:nvSpPr>
+          <p:cNvPr id="7" name="TextBox 6"/>
+          <p:cNvSpPr txBox="1"/>
+          <p:nvPr/>
+        </p:nvSpPr>
+        <p:spPr>
+          <a:xfrm>
             <a:off x="658368" y="1847088"/>
             <a:ext cx="4526280" cy="310896"/>
           </a:xfrm>
@@ -5312,7 +5382,7 @@
       </p:sp>
       <p:sp>
         <p:nvSpPr>
-          <p:cNvPr id="7" name="TextBox 6"/>
+          <p:cNvPr id="8" name="TextBox 7"/>
           <p:cNvSpPr txBox="1"/>
           <p:nvPr/>
         </p:nvSpPr>
@@ -5347,7 +5417,7 @@
       </p:sp>
       <p:sp>
         <p:nvSpPr>
-          <p:cNvPr id="8" name="Rectangle 7"/>
+          <p:cNvPr id="9" name="Rectangle 8"/>
           <p:cNvSpPr/>
           <p:nvPr/>
         </p:nvSpPr>
@@ -5392,7 +5462,7 @@
       </p:sp>
       <p:sp>
         <p:nvSpPr>
-          <p:cNvPr id="9" name="TextBox 8"/>
+          <p:cNvPr id="10" name="TextBox 9"/>
           <p:cNvSpPr txBox="1"/>
           <p:nvPr/>
         </p:nvSpPr>
@@ -5427,7 +5497,7 @@
       </p:sp>
       <p:sp>
         <p:nvSpPr>
-          <p:cNvPr id="10" name="TextBox 9"/>
+          <p:cNvPr id="11" name="TextBox 10"/>
           <p:cNvSpPr txBox="1"/>
           <p:nvPr/>
         </p:nvSpPr>
@@ -5462,7 +5532,7 @@
       </p:sp>
       <p:sp>
         <p:nvSpPr>
-          <p:cNvPr id="11" name="TextBox 10"/>
+          <p:cNvPr id="12" name="TextBox 11"/>
           <p:cNvSpPr txBox="1"/>
           <p:nvPr/>
         </p:nvSpPr>
@@ -5497,7 +5567,7 @@
       </p:sp>
       <p:sp>
         <p:nvSpPr>
-          <p:cNvPr id="12" name="Rectangle 11"/>
+          <p:cNvPr id="13" name="Rectangle 12"/>
           <p:cNvSpPr/>
           <p:nvPr/>
         </p:nvSpPr>
@@ -5542,7 +5612,7 @@
       </p:sp>
       <p:sp>
         <p:nvSpPr>
-          <p:cNvPr id="13" name="TextBox 12"/>
+          <p:cNvPr id="14" name="TextBox 13"/>
           <p:cNvSpPr txBox="1"/>
           <p:nvPr/>
         </p:nvSpPr>
@@ -5577,7 +5647,7 @@
       </p:sp>
       <p:sp>
         <p:nvSpPr>
-          <p:cNvPr id="14" name="TextBox 13"/>
+          <p:cNvPr id="15" name="TextBox 14"/>
           <p:cNvSpPr txBox="1"/>
           <p:nvPr/>
         </p:nvSpPr>
@@ -5612,7 +5682,7 @@
       </p:sp>
       <p:sp>
         <p:nvSpPr>
-          <p:cNvPr id="15" name="Rectangle 14"/>
+          <p:cNvPr id="16" name="Rectangle 15"/>
           <p:cNvSpPr/>
           <p:nvPr/>
         </p:nvSpPr>
@@ -5657,7 +5727,7 @@
       </p:sp>
       <p:sp>
         <p:nvSpPr>
-          <p:cNvPr id="16" name="TextBox 15"/>
+          <p:cNvPr id="17" name="TextBox 16"/>
           <p:cNvSpPr txBox="1"/>
           <p:nvPr/>
         </p:nvSpPr>
@@ -5692,7 +5762,7 @@
       </p:sp>
       <p:sp>
         <p:nvSpPr>
-          <p:cNvPr id="17" name="TextBox 16"/>
+          <p:cNvPr id="18" name="TextBox 17"/>
           <p:cNvSpPr txBox="1"/>
           <p:nvPr/>
         </p:nvSpPr>
@@ -5909,6 +5979,41 @@
         </p:nvSpPr>
         <p:spPr>
           <a:xfrm>
+            <a:off x="1810512" y="1353312"/>
+            <a:ext cx="9464040" cy="274320"/>
+          </a:xfrm>
+          <a:prstGeom prst="rect">
+            <a:avLst/>
+          </a:prstGeom>
+          <a:noFill/>
+        </p:spPr>
+        <p:txBody>
+          <a:bodyPr wrap="square" lIns="18288" rIns="18288" tIns="18288" bIns="18288" anchor="t">
+            <a:spAutoFit/>
+          </a:bodyPr>
+          <a:lstStyle/>
+          <a:p>
+            <a:pPr algn="l"/>
+            <a:r>
+              <a:rPr sz="1400" b="1">
+                <a:solidFill>
+                  <a:srgbClr val="539976"/>
+                </a:solidFill>
+                <a:latin typeface="Arial"/>
+              </a:rPr>
+              <a:t>Uthoff et al. · 2023 · Helmholtz-UFZ, Leipzig (Alemanha)</a:t>
+            </a:r>
+          </a:p>
+        </p:txBody>
+      </p:sp>
+      <p:sp>
+        <p:nvSpPr>
+          <p:cNvPr id="7" name="TextBox 6"/>
+          <p:cNvSpPr txBox="1"/>
+          <p:nvPr/>
+        </p:nvSpPr>
+        <p:spPr>
+          <a:xfrm>
             <a:off x="658368" y="1847088"/>
             <a:ext cx="4526280" cy="310896"/>
           </a:xfrm>
@@ -5938,7 +6043,7 @@
       </p:sp>
       <p:sp>
         <p:nvSpPr>
-          <p:cNvPr id="7" name="TextBox 6"/>
+          <p:cNvPr id="8" name="TextBox 7"/>
           <p:cNvSpPr txBox="1"/>
           <p:nvPr/>
         </p:nvSpPr>
@@ -5973,7 +6078,7 @@
       </p:sp>
       <p:sp>
         <p:nvSpPr>
-          <p:cNvPr id="8" name="Rectangle 7"/>
+          <p:cNvPr id="9" name="Rectangle 8"/>
           <p:cNvSpPr/>
           <p:nvPr/>
         </p:nvSpPr>
@@ -6018,7 +6123,7 @@
       </p:sp>
       <p:sp>
         <p:nvSpPr>
-          <p:cNvPr id="9" name="TextBox 8"/>
+          <p:cNvPr id="10" name="TextBox 9"/>
           <p:cNvSpPr txBox="1"/>
           <p:nvPr/>
         </p:nvSpPr>
@@ -6053,7 +6158,7 @@
       </p:sp>
       <p:sp>
         <p:nvSpPr>
-          <p:cNvPr id="10" name="TextBox 9"/>
+          <p:cNvPr id="11" name="TextBox 10"/>
           <p:cNvSpPr txBox="1"/>
           <p:nvPr/>
         </p:nvSpPr>
@@ -6088,7 +6193,7 @@
       </p:sp>
       <p:sp>
         <p:nvSpPr>
-          <p:cNvPr id="11" name="TextBox 10"/>
+          <p:cNvPr id="12" name="TextBox 11"/>
           <p:cNvSpPr txBox="1"/>
           <p:nvPr/>
         </p:nvSpPr>
@@ -6123,7 +6228,7 @@
       </p:sp>
       <p:sp>
         <p:nvSpPr>
-          <p:cNvPr id="12" name="Rectangle 11"/>
+          <p:cNvPr id="13" name="Rectangle 12"/>
           <p:cNvSpPr/>
           <p:nvPr/>
         </p:nvSpPr>
@@ -6168,7 +6273,7 @@
       </p:sp>
       <p:sp>
         <p:nvSpPr>
-          <p:cNvPr id="13" name="TextBox 12"/>
+          <p:cNvPr id="14" name="TextBox 13"/>
           <p:cNvSpPr txBox="1"/>
           <p:nvPr/>
         </p:nvSpPr>
@@ -6203,7 +6308,7 @@
       </p:sp>
       <p:sp>
         <p:nvSpPr>
-          <p:cNvPr id="14" name="TextBox 13"/>
+          <p:cNvPr id="15" name="TextBox 14"/>
           <p:cNvSpPr txBox="1"/>
           <p:nvPr/>
         </p:nvSpPr>
@@ -6238,7 +6343,7 @@
       </p:sp>
       <p:sp>
         <p:nvSpPr>
-          <p:cNvPr id="15" name="Rectangle 14"/>
+          <p:cNvPr id="16" name="Rectangle 15"/>
           <p:cNvSpPr/>
           <p:nvPr/>
         </p:nvSpPr>
@@ -6283,7 +6388,7 @@
       </p:sp>
       <p:sp>
         <p:nvSpPr>
-          <p:cNvPr id="16" name="TextBox 15"/>
+          <p:cNvPr id="17" name="TextBox 16"/>
           <p:cNvSpPr txBox="1"/>
           <p:nvPr/>
         </p:nvSpPr>
@@ -6318,7 +6423,7 @@
       </p:sp>
       <p:sp>
         <p:nvSpPr>
-          <p:cNvPr id="17" name="TextBox 16"/>
+          <p:cNvPr id="18" name="TextBox 17"/>
           <p:cNvSpPr txBox="1"/>
           <p:nvPr/>
         </p:nvSpPr>
@@ -6535,6 +6640,41 @@
         </p:nvSpPr>
         <p:spPr>
           <a:xfrm>
+            <a:off x="1810512" y="1353312"/>
+            <a:ext cx="9464040" cy="274320"/>
+          </a:xfrm>
+          <a:prstGeom prst="rect">
+            <a:avLst/>
+          </a:prstGeom>
+          <a:noFill/>
+        </p:spPr>
+        <p:txBody>
+          <a:bodyPr wrap="square" lIns="18288" rIns="18288" tIns="18288" bIns="18288" anchor="t">
+            <a:spAutoFit/>
+          </a:bodyPr>
+          <a:lstStyle/>
+          <a:p>
+            <a:pPr algn="l"/>
+            <a:r>
+              <a:rPr sz="1400" b="1">
+                <a:solidFill>
+                  <a:srgbClr val="458CC4"/>
+                </a:solidFill>
+                <a:latin typeface="Arial"/>
+              </a:rPr>
+              <a:t>Tashakkori et al. · 2021 · Appalachian State University (EUA)</a:t>
+            </a:r>
+          </a:p>
+        </p:txBody>
+      </p:sp>
+      <p:sp>
+        <p:nvSpPr>
+          <p:cNvPr id="7" name="TextBox 6"/>
+          <p:cNvSpPr txBox="1"/>
+          <p:nvPr/>
+        </p:nvSpPr>
+        <p:spPr>
+          <a:xfrm>
             <a:off x="658368" y="1847088"/>
             <a:ext cx="4526280" cy="310896"/>
           </a:xfrm>
@@ -6564,7 +6704,7 @@
       </p:sp>
       <p:sp>
         <p:nvSpPr>
-          <p:cNvPr id="7" name="TextBox 6"/>
+          <p:cNvPr id="8" name="TextBox 7"/>
           <p:cNvSpPr txBox="1"/>
           <p:nvPr/>
         </p:nvSpPr>
@@ -6599,7 +6739,7 @@
       </p:sp>
       <p:sp>
         <p:nvSpPr>
-          <p:cNvPr id="8" name="Rectangle 7"/>
+          <p:cNvPr id="9" name="Rectangle 8"/>
           <p:cNvSpPr/>
           <p:nvPr/>
         </p:nvSpPr>
@@ -6644,7 +6784,7 @@
       </p:sp>
       <p:sp>
         <p:nvSpPr>
-          <p:cNvPr id="9" name="TextBox 8"/>
+          <p:cNvPr id="10" name="TextBox 9"/>
           <p:cNvSpPr txBox="1"/>
           <p:nvPr/>
         </p:nvSpPr>
@@ -6679,7 +6819,7 @@
       </p:sp>
       <p:sp>
         <p:nvSpPr>
-          <p:cNvPr id="10" name="TextBox 9"/>
+          <p:cNvPr id="11" name="TextBox 10"/>
           <p:cNvSpPr txBox="1"/>
           <p:nvPr/>
         </p:nvSpPr>
@@ -6714,7 +6854,7 @@
       </p:sp>
       <p:sp>
         <p:nvSpPr>
-          <p:cNvPr id="11" name="TextBox 10"/>
+          <p:cNvPr id="12" name="TextBox 11"/>
           <p:cNvSpPr txBox="1"/>
           <p:nvPr/>
         </p:nvSpPr>
@@ -6749,7 +6889,7 @@
       </p:sp>
       <p:sp>
         <p:nvSpPr>
-          <p:cNvPr id="12" name="Rectangle 11"/>
+          <p:cNvPr id="13" name="Rectangle 12"/>
           <p:cNvSpPr/>
           <p:nvPr/>
         </p:nvSpPr>
@@ -6794,7 +6934,7 @@
       </p:sp>
       <p:sp>
         <p:nvSpPr>
-          <p:cNvPr id="13" name="TextBox 12"/>
+          <p:cNvPr id="14" name="TextBox 13"/>
           <p:cNvSpPr txBox="1"/>
           <p:nvPr/>
         </p:nvSpPr>
@@ -6829,7 +6969,7 @@
       </p:sp>
       <p:sp>
         <p:nvSpPr>
-          <p:cNvPr id="14" name="TextBox 13"/>
+          <p:cNvPr id="15" name="TextBox 14"/>
           <p:cNvSpPr txBox="1"/>
           <p:nvPr/>
         </p:nvSpPr>
@@ -6864,7 +7004,7 @@
       </p:sp>
       <p:sp>
         <p:nvSpPr>
-          <p:cNvPr id="15" name="Rectangle 14"/>
+          <p:cNvPr id="16" name="Rectangle 15"/>
           <p:cNvSpPr/>
           <p:nvPr/>
         </p:nvSpPr>
@@ -6909,7 +7049,7 @@
       </p:sp>
       <p:sp>
         <p:nvSpPr>
-          <p:cNvPr id="16" name="TextBox 15"/>
+          <p:cNvPr id="17" name="TextBox 16"/>
           <p:cNvSpPr txBox="1"/>
           <p:nvPr/>
         </p:nvSpPr>
@@ -6944,7 +7084,7 @@
       </p:sp>
       <p:sp>
         <p:nvSpPr>
-          <p:cNvPr id="17" name="TextBox 16"/>
+          <p:cNvPr id="18" name="TextBox 17"/>
           <p:cNvSpPr txBox="1"/>
           <p:nvPr/>
         </p:nvSpPr>
@@ -7161,6 +7301,41 @@
         </p:nvSpPr>
         <p:spPr>
           <a:xfrm>
+            <a:off x="1810512" y="1353312"/>
+            <a:ext cx="9464040" cy="274320"/>
+          </a:xfrm>
+          <a:prstGeom prst="rect">
+            <a:avLst/>
+          </a:prstGeom>
+          <a:noFill/>
+        </p:spPr>
+        <p:txBody>
+          <a:bodyPr wrap="square" lIns="18288" rIns="18288" tIns="18288" bIns="18288" anchor="t">
+            <a:spAutoFit/>
+          </a:bodyPr>
+          <a:lstStyle/>
+          <a:p>
+            <a:pPr algn="l"/>
+            <a:r>
+              <a:rPr sz="1400" b="1">
+                <a:solidFill>
+                  <a:srgbClr val="DA6F5C"/>
+                </a:solidFill>
+                <a:latin typeface="Arial"/>
+              </a:rPr>
+              <a:t>Henry et al. · 2019 · McGill University, Quebec (Canadá)</a:t>
+            </a:r>
+          </a:p>
+        </p:txBody>
+      </p:sp>
+      <p:sp>
+        <p:nvSpPr>
+          <p:cNvPr id="7" name="TextBox 6"/>
+          <p:cNvSpPr txBox="1"/>
+          <p:nvPr/>
+        </p:nvSpPr>
+        <p:spPr>
+          <a:xfrm>
             <a:off x="658368" y="1847088"/>
             <a:ext cx="4526280" cy="310896"/>
           </a:xfrm>
@@ -7190,7 +7365,7 @@
       </p:sp>
       <p:sp>
         <p:nvSpPr>
-          <p:cNvPr id="7" name="TextBox 6"/>
+          <p:cNvPr id="8" name="TextBox 7"/>
           <p:cNvSpPr txBox="1"/>
           <p:nvPr/>
         </p:nvSpPr>
@@ -7225,7 +7400,7 @@
       </p:sp>
       <p:sp>
         <p:nvSpPr>
-          <p:cNvPr id="8" name="Rectangle 7"/>
+          <p:cNvPr id="9" name="Rectangle 8"/>
           <p:cNvSpPr/>
           <p:nvPr/>
         </p:nvSpPr>
@@ -7270,7 +7445,7 @@
       </p:sp>
       <p:sp>
         <p:nvSpPr>
-          <p:cNvPr id="9" name="TextBox 8"/>
+          <p:cNvPr id="10" name="TextBox 9"/>
           <p:cNvSpPr txBox="1"/>
           <p:nvPr/>
         </p:nvSpPr>
@@ -7305,7 +7480,7 @@
       </p:sp>
       <p:sp>
         <p:nvSpPr>
-          <p:cNvPr id="10" name="TextBox 9"/>
+          <p:cNvPr id="11" name="TextBox 10"/>
           <p:cNvSpPr txBox="1"/>
           <p:nvPr/>
         </p:nvSpPr>
@@ -7340,7 +7515,7 @@
       </p:sp>
       <p:sp>
         <p:nvSpPr>
-          <p:cNvPr id="11" name="TextBox 10"/>
+          <p:cNvPr id="12" name="TextBox 11"/>
           <p:cNvSpPr txBox="1"/>
           <p:nvPr/>
         </p:nvSpPr>
@@ -7375,7 +7550,7 @@
       </p:sp>
       <p:sp>
         <p:nvSpPr>
-          <p:cNvPr id="12" name="Rectangle 11"/>
+          <p:cNvPr id="13" name="Rectangle 12"/>
           <p:cNvSpPr/>
           <p:nvPr/>
         </p:nvSpPr>
@@ -7420,7 +7595,7 @@
       </p:sp>
       <p:sp>
         <p:nvSpPr>
-          <p:cNvPr id="13" name="TextBox 12"/>
+          <p:cNvPr id="14" name="TextBox 13"/>
           <p:cNvSpPr txBox="1"/>
           <p:nvPr/>
         </p:nvSpPr>
@@ -7455,7 +7630,7 @@
       </p:sp>
       <p:sp>
         <p:nvSpPr>
-          <p:cNvPr id="14" name="TextBox 13"/>
+          <p:cNvPr id="15" name="TextBox 14"/>
           <p:cNvSpPr txBox="1"/>
           <p:nvPr/>
         </p:nvSpPr>
@@ -7490,7 +7665,7 @@
       </p:sp>
       <p:sp>
         <p:nvSpPr>
-          <p:cNvPr id="15" name="Rectangle 14"/>
+          <p:cNvPr id="16" name="Rectangle 15"/>
           <p:cNvSpPr/>
           <p:nvPr/>
         </p:nvSpPr>
@@ -7535,7 +7710,7 @@
       </p:sp>
       <p:sp>
         <p:nvSpPr>
-          <p:cNvPr id="16" name="TextBox 15"/>
+          <p:cNvPr id="17" name="TextBox 16"/>
           <p:cNvSpPr txBox="1"/>
           <p:nvPr/>
         </p:nvSpPr>
@@ -7570,7 +7745,7 @@
       </p:sp>
       <p:sp>
         <p:nvSpPr>
-          <p:cNvPr id="17" name="TextBox 16"/>
+          <p:cNvPr id="18" name="TextBox 17"/>
           <p:cNvSpPr txBox="1"/>
           <p:nvPr/>
         </p:nvSpPr>
@@ -7787,6 +7962,41 @@
         </p:nvSpPr>
         <p:spPr>
           <a:xfrm>
+            <a:off x="1810512" y="1353312"/>
+            <a:ext cx="9464040" cy="274320"/>
+          </a:xfrm>
+          <a:prstGeom prst="rect">
+            <a:avLst/>
+          </a:prstGeom>
+          <a:noFill/>
+        </p:spPr>
+        <p:txBody>
+          <a:bodyPr wrap="square" lIns="18288" rIns="18288" tIns="18288" bIns="18288" anchor="t">
+            <a:spAutoFit/>
+          </a:bodyPr>
+          <a:lstStyle/>
+          <a:p>
+            <a:pPr algn="l"/>
+            <a:r>
+              <a:rPr sz="1400" b="1">
+                <a:solidFill>
+                  <a:srgbClr val="539976"/>
+                </a:solidFill>
+                <a:latin typeface="Arial"/>
+              </a:rPr>
+              <a:t>Tu et al. · 2016 · Aarhus University (Dinamarca)</a:t>
+            </a:r>
+          </a:p>
+        </p:txBody>
+      </p:sp>
+      <p:sp>
+        <p:nvSpPr>
+          <p:cNvPr id="7" name="TextBox 6"/>
+          <p:cNvSpPr txBox="1"/>
+          <p:nvPr/>
+        </p:nvSpPr>
+        <p:spPr>
+          <a:xfrm>
             <a:off x="658368" y="1847088"/>
             <a:ext cx="4526280" cy="310896"/>
           </a:xfrm>
@@ -7816,7 +8026,7 @@
       </p:sp>
       <p:sp>
         <p:nvSpPr>
-          <p:cNvPr id="7" name="TextBox 6"/>
+          <p:cNvPr id="8" name="TextBox 7"/>
           <p:cNvSpPr txBox="1"/>
           <p:nvPr/>
         </p:nvSpPr>
@@ -7851,7 +8061,7 @@
       </p:sp>
       <p:sp>
         <p:nvSpPr>
-          <p:cNvPr id="8" name="Rectangle 7"/>
+          <p:cNvPr id="9" name="Rectangle 8"/>
           <p:cNvSpPr/>
           <p:nvPr/>
         </p:nvSpPr>
@@ -7896,7 +8106,7 @@
       </p:sp>
       <p:sp>
         <p:nvSpPr>
-          <p:cNvPr id="9" name="TextBox 8"/>
+          <p:cNvPr id="10" name="TextBox 9"/>
           <p:cNvSpPr txBox="1"/>
           <p:nvPr/>
         </p:nvSpPr>
@@ -7931,7 +8141,7 @@
       </p:sp>
       <p:sp>
         <p:nvSpPr>
-          <p:cNvPr id="10" name="TextBox 9"/>
+          <p:cNvPr id="11" name="TextBox 10"/>
           <p:cNvSpPr txBox="1"/>
           <p:nvPr/>
         </p:nvSpPr>
@@ -7966,7 +8176,7 @@
       </p:sp>
       <p:sp>
         <p:nvSpPr>
-          <p:cNvPr id="11" name="TextBox 10"/>
+          <p:cNvPr id="12" name="TextBox 11"/>
           <p:cNvSpPr txBox="1"/>
           <p:nvPr/>
         </p:nvSpPr>
@@ -8001,7 +8211,7 @@
       </p:sp>
       <p:sp>
         <p:nvSpPr>
-          <p:cNvPr id="12" name="Rectangle 11"/>
+          <p:cNvPr id="13" name="Rectangle 12"/>
           <p:cNvSpPr/>
           <p:nvPr/>
         </p:nvSpPr>
@@ -8046,7 +8256,7 @@
       </p:sp>
       <p:sp>
         <p:nvSpPr>
-          <p:cNvPr id="13" name="TextBox 12"/>
+          <p:cNvPr id="14" name="TextBox 13"/>
           <p:cNvSpPr txBox="1"/>
           <p:nvPr/>
         </p:nvSpPr>
@@ -8081,7 +8291,7 @@
       </p:sp>
       <p:sp>
         <p:nvSpPr>
-          <p:cNvPr id="14" name="TextBox 13"/>
+          <p:cNvPr id="15" name="TextBox 14"/>
           <p:cNvSpPr txBox="1"/>
           <p:nvPr/>
         </p:nvSpPr>
@@ -8116,7 +8326,7 @@
       </p:sp>
       <p:sp>
         <p:nvSpPr>
-          <p:cNvPr id="15" name="Rectangle 14"/>
+          <p:cNvPr id="16" name="Rectangle 15"/>
           <p:cNvSpPr/>
           <p:nvPr/>
         </p:nvSpPr>
@@ -8161,7 +8371,7 @@
       </p:sp>
       <p:sp>
         <p:nvSpPr>
-          <p:cNvPr id="16" name="TextBox 15"/>
+          <p:cNvPr id="17" name="TextBox 16"/>
           <p:cNvSpPr txBox="1"/>
           <p:nvPr/>
         </p:nvSpPr>
@@ -8196,7 +8406,7 @@
       </p:sp>
       <p:sp>
         <p:nvSpPr>
-          <p:cNvPr id="17" name="TextBox 16"/>
+          <p:cNvPr id="18" name="TextBox 17"/>
           <p:cNvSpPr txBox="1"/>
           <p:nvPr/>
         </p:nvSpPr>

</xml_diff>